<commit_message>
PDF va PPTX da prognoz foydasi 3.616 mlrd ga moslandi
PDF (3-sahifa, KPI Dashboard): Prognoz sof foyda 9.04 -> 3.616 mlrd,
o'sish +249.0% -> +39.5%, marja 3.28% -> 1.31%. Faqat 3-sahifa qayta
render qilinib mavjud PDF ga almashtirildi, qolgan sahifalar o'zgarmadi.

PPTX (20-slayd, Investor ulushi ssenariylari): investor foydasi, ROI va
qoplanish muddati 9.04 mlrd asosida hisoblangan edi; 3.616 mlrd
(= 9.04 x 0.4) asosida qayta hisoblandi.

Co-Authored-By: Claude Opus 5.5 <noreply@anthropic.com>
Claude-Session: https://claude.ai/code/session_01LhnBPSWV4sNya7mUxQe2Bv
</commit_message>
<xml_diff>
--- a/AKFA_Dilerlik_Investor_Prezentatsiyasi.pptx
+++ b/AKFA_Dilerlik_Investor_Prezentatsiyasi.pptx
@@ -5415,7 +5415,7 @@
       </p:grpSpPr>
       <p:pic>
         <p:nvPicPr>
-          <p:cNvPr id="2" name="Image 0" descr="C:\Users\WECAN\Downloads\akfa invest 6040 new\assets\hero-bg.jpg">    </p:cNvPr>
+          <p:cNvPr id="2" name="Image 0" descr="/home/user/akfa-invest-6040/assets/hero-bg.jpg">    </p:cNvPr>
           <p:cNvPicPr>
             <a:picLocks noChangeAspect="1"/>
           </p:cNvPicPr>
@@ -30685,7 +30685,7 @@
                           <a:ea typeface="Calibri" pitchFamily="34" charset="-122"/>
                           <a:cs typeface="Calibri" pitchFamily="34" charset="-120"/>
                         </a:rPr>
-                        <a:t>$140,800</a:t>
+                        <a:t>$56,320</a:t>
                       </a:r>
                       <a:endParaRPr lang="en-US" sz="950" dirty="0">
                         <a:latin typeface="Calibri" charset="0"/>
@@ -30753,7 +30753,7 @@
                           <a:ea typeface="Calibri" pitchFamily="34" charset="-122"/>
                           <a:cs typeface="Calibri" pitchFamily="34" charset="-120"/>
                         </a:rPr>
-                        <a:t>7.0% / yil</a:t>
+                        <a:t>2.8% / yil</a:t>
                       </a:r>
                       <a:endParaRPr lang="en-US" sz="950" dirty="0">
                         <a:latin typeface="Calibri" charset="0"/>
@@ -30821,7 +30821,7 @@
                           <a:ea typeface="Calibri" pitchFamily="34" charset="-122"/>
                           <a:cs typeface="Calibri" pitchFamily="34" charset="-120"/>
                         </a:rPr>
-                        <a:t>14.2 yil</a:t>
+                        <a:t>35.5 yil</a:t>
                       </a:r>
                       <a:endParaRPr lang="en-US" sz="950" dirty="0">
                         <a:latin typeface="Calibri" charset="0"/>
@@ -31095,7 +31095,7 @@
                           <a:ea typeface="Calibri" pitchFamily="34" charset="-122"/>
                           <a:cs typeface="Calibri" pitchFamily="34" charset="-120"/>
                         </a:rPr>
-                        <a:t>$176,000</a:t>
+                        <a:t>$70,400</a:t>
                       </a:r>
                       <a:endParaRPr lang="en-US" sz="950" dirty="0">
                         <a:latin typeface="Calibri" charset="0"/>
@@ -31163,7 +31163,7 @@
                           <a:ea typeface="Calibri" pitchFamily="34" charset="-122"/>
                           <a:cs typeface="Calibri" pitchFamily="34" charset="-120"/>
                         </a:rPr>
-                        <a:t>8.8% / yil</a:t>
+                        <a:t>3.5% / yil</a:t>
                       </a:r>
                       <a:endParaRPr lang="en-US" sz="950" dirty="0">
                         <a:latin typeface="Calibri" charset="0"/>
@@ -31231,7 +31231,7 @@
                           <a:ea typeface="Calibri" pitchFamily="34" charset="-122"/>
                           <a:cs typeface="Calibri" pitchFamily="34" charset="-120"/>
                         </a:rPr>
-                        <a:t>11.4 yil</a:t>
+                        <a:t>28.4 yil</a:t>
                       </a:r>
                       <a:endParaRPr lang="en-US" sz="950" dirty="0">
                         <a:latin typeface="Calibri" charset="0"/>
@@ -31505,7 +31505,7 @@
                           <a:ea typeface="Calibri" pitchFamily="34" charset="-122"/>
                           <a:cs typeface="Calibri" pitchFamily="34" charset="-120"/>
                         </a:rPr>
-                        <a:t>$211,200</a:t>
+                        <a:t>$84,480</a:t>
                       </a:r>
                       <a:endParaRPr lang="en-US" sz="950" dirty="0">
                         <a:latin typeface="Calibri" charset="0"/>
@@ -31573,7 +31573,7 @@
                           <a:ea typeface="Calibri" pitchFamily="34" charset="-122"/>
                           <a:cs typeface="Calibri" pitchFamily="34" charset="-120"/>
                         </a:rPr>
-                        <a:t>10.6% / yil</a:t>
+                        <a:t>4.2% / yil</a:t>
                       </a:r>
                       <a:endParaRPr lang="en-US" sz="950" dirty="0">
                         <a:latin typeface="Calibri" charset="0"/>
@@ -31641,7 +31641,7 @@
                           <a:ea typeface="Calibri" pitchFamily="34" charset="-122"/>
                           <a:cs typeface="Calibri" pitchFamily="34" charset="-120"/>
                         </a:rPr>
-                        <a:t>9.5 yil</a:t>
+                        <a:t>23.7 yil</a:t>
                       </a:r>
                       <a:endParaRPr lang="en-US" sz="950" dirty="0">
                         <a:latin typeface="Calibri" charset="0"/>
@@ -31915,7 +31915,7 @@
                           <a:ea typeface="Calibri" pitchFamily="34" charset="-122"/>
                           <a:cs typeface="Calibri" pitchFamily="34" charset="-120"/>
                         </a:rPr>
-                        <a:t>$246,400</a:t>
+                        <a:t>$98,560</a:t>
                       </a:r>
                       <a:endParaRPr lang="en-US" sz="950" dirty="0">
                         <a:latin typeface="Calibri" charset="0"/>
@@ -31983,7 +31983,7 @@
                           <a:ea typeface="Calibri" pitchFamily="34" charset="-122"/>
                           <a:cs typeface="Calibri" pitchFamily="34" charset="-120"/>
                         </a:rPr>
-                        <a:t>12.3% / yil</a:t>
+                        <a:t>4.9% / yil</a:t>
                       </a:r>
                       <a:endParaRPr lang="en-US" sz="950" dirty="0">
                         <a:latin typeface="Calibri" charset="0"/>
@@ -32051,7 +32051,7 @@
                           <a:ea typeface="Calibri" pitchFamily="34" charset="-122"/>
                           <a:cs typeface="Calibri" pitchFamily="34" charset="-120"/>
                         </a:rPr>
-                        <a:t>8.1 yil</a:t>
+                        <a:t>20.3 yil</a:t>
                       </a:r>
                       <a:endParaRPr lang="en-US" sz="950" dirty="0">
                         <a:latin typeface="Calibri" charset="0"/>
@@ -32325,7 +32325,7 @@
                           <a:ea typeface="Calibri" pitchFamily="34" charset="-122"/>
                           <a:cs typeface="Calibri" pitchFamily="34" charset="-120"/>
                         </a:rPr>
-                        <a:t>$281,600</a:t>
+                        <a:t>$112,640</a:t>
                       </a:r>
                       <a:endParaRPr lang="en-US" sz="950" dirty="0">
                         <a:latin typeface="Calibri" charset="0"/>
@@ -32393,7 +32393,7 @@
                           <a:ea typeface="Calibri" pitchFamily="34" charset="-122"/>
                           <a:cs typeface="Calibri" pitchFamily="34" charset="-120"/>
                         </a:rPr>
-                        <a:t>14.1% / yil</a:t>
+                        <a:t>5.6% / yil</a:t>
                       </a:r>
                       <a:endParaRPr lang="en-US" sz="950" dirty="0">
                         <a:latin typeface="Calibri" charset="0"/>
@@ -32461,7 +32461,7 @@
                           <a:ea typeface="Calibri" pitchFamily="34" charset="-122"/>
                           <a:cs typeface="Calibri" pitchFamily="34" charset="-120"/>
                         </a:rPr>
-                        <a:t>7.1 yil</a:t>
+                        <a:t>17.8 yil</a:t>
                       </a:r>
                       <a:endParaRPr lang="en-US" sz="950" dirty="0">
                         <a:latin typeface="Calibri" charset="0"/>
@@ -35502,7 +35502,7 @@
       </p:grpSpPr>
       <p:pic>
         <p:nvPicPr>
-          <p:cNvPr id="2" name="Image 0" descr="C:\Users\WECAN\Downloads\akfa invest 6040 new\assets\construction.jpg">    </p:cNvPr>
+          <p:cNvPr id="2" name="Image 0" descr="/home/user/akfa-invest-6040/assets/construction.jpg">    </p:cNvPr>
           <p:cNvPicPr>
             <a:picLocks noChangeAspect="1"/>
           </p:cNvPicPr>
@@ -39701,7 +39701,7 @@
       </p:sp>
       <p:pic>
         <p:nvPicPr>
-          <p:cNvPr id="5" name="Image 0" descr="C:\Users\WECAN\Downloads\akfa invest 6040 new\assets\warehouse.jpg">    </p:cNvPr>
+          <p:cNvPr id="5" name="Image 0" descr="/home/user/akfa-invest-6040/assets/warehouse.jpg">    </p:cNvPr>
           <p:cNvPicPr>
             <a:picLocks noChangeAspect="1"/>
           </p:cNvPicPr>

</xml_diff>